<commit_message>
changed the api picture
</commit_message>
<xml_diff>
--- a/assets/humanoidRobotRestoration.pptx
+++ b/assets/humanoidRobotRestoration.pptx
@@ -167,7 +167,7 @@
           <a:noFill/>
           <a:extLst>
             <a:ext uri="{909E8E84-426E-40dd-AFC4-6F175D3DCCD1}">
-              <a14:hiddenFill xmlns:a14="http://schemas.microsoft.com/office/drawing/2010/main" xmlns="">
+              <a14:hiddenFill xmlns="" xmlns:a14="http://schemas.microsoft.com/office/drawing/2010/main">
                 <a:solidFill>
                   <a:srgbClr val="FFFFFF"/>
                 </a:solidFill>
@@ -227,7 +227,7 @@
             </a:ln>
             <a:extLst>
               <a:ext uri="{91240B29-F687-4f45-9708-019B960494DF}">
-                <a14:hiddenLine xmlns:a14="http://schemas.microsoft.com/office/drawing/2010/main" xmlns="" w="9525">
+                <a14:hiddenLine xmlns="" xmlns:a14="http://schemas.microsoft.com/office/drawing/2010/main" w="9525">
                   <a:solidFill>
                     <a:srgbClr val="000000"/>
                   </a:solidFill>
@@ -324,7 +324,7 @@
             </a:ln>
             <a:extLst>
               <a:ext uri="{91240B29-F687-4f45-9708-019B960494DF}">
-                <a14:hiddenLine xmlns:a14="http://schemas.microsoft.com/office/drawing/2010/main" xmlns="" w="9525">
+                <a14:hiddenLine xmlns="" xmlns:a14="http://schemas.microsoft.com/office/drawing/2010/main" w="9525">
                   <a:solidFill>
                     <a:srgbClr val="000000"/>
                   </a:solidFill>
@@ -421,7 +421,7 @@
             </a:ln>
             <a:extLst>
               <a:ext uri="{91240B29-F687-4f45-9708-019B960494DF}">
-                <a14:hiddenLine xmlns:a14="http://schemas.microsoft.com/office/drawing/2010/main" xmlns="" w="9525">
+                <a14:hiddenLine xmlns="" xmlns:a14="http://schemas.microsoft.com/office/drawing/2010/main" w="9525">
                   <a:solidFill>
                     <a:srgbClr val="000000"/>
                   </a:solidFill>
@@ -462,7 +462,7 @@
             </a:ln>
             <a:extLst>
               <a:ext uri="{91240B29-F687-4f45-9708-019B960494DF}">
-                <a14:hiddenLine xmlns:a14="http://schemas.microsoft.com/office/drawing/2010/main" xmlns="" w="9525">
+                <a14:hiddenLine xmlns="" xmlns:a14="http://schemas.microsoft.com/office/drawing/2010/main" w="9525">
                   <a:solidFill>
                     <a:srgbClr val="000000"/>
                   </a:solidFill>
@@ -559,7 +559,7 @@
             </a:ln>
             <a:extLst>
               <a:ext uri="{91240B29-F687-4f45-9708-019B960494DF}">
-                <a14:hiddenLine xmlns:a14="http://schemas.microsoft.com/office/drawing/2010/main" xmlns="" w="9525">
+                <a14:hiddenLine xmlns="" xmlns:a14="http://schemas.microsoft.com/office/drawing/2010/main" w="9525">
                   <a:solidFill>
                     <a:srgbClr val="000000"/>
                   </a:solidFill>
@@ -628,7 +628,7 @@
             </a:ln>
             <a:extLst>
               <a:ext uri="{91240B29-F687-4f45-9708-019B960494DF}">
-                <a14:hiddenLine xmlns:a14="http://schemas.microsoft.com/office/drawing/2010/main" xmlns="" w="9525">
+                <a14:hiddenLine xmlns="" xmlns:a14="http://schemas.microsoft.com/office/drawing/2010/main" w="9525">
                   <a:solidFill>
                     <a:srgbClr val="000000"/>
                   </a:solidFill>
@@ -697,7 +697,7 @@
             </a:ln>
             <a:extLst>
               <a:ext uri="{91240B29-F687-4f45-9708-019B960494DF}">
-                <a14:hiddenLine xmlns:a14="http://schemas.microsoft.com/office/drawing/2010/main" xmlns="" w="9525">
+                <a14:hiddenLine xmlns="" xmlns:a14="http://schemas.microsoft.com/office/drawing/2010/main" w="9525">
                   <a:solidFill>
                     <a:srgbClr val="000000"/>
                   </a:solidFill>
@@ -794,7 +794,7 @@
             </a:ln>
             <a:extLst>
               <a:ext uri="{91240B29-F687-4f45-9708-019B960494DF}">
-                <a14:hiddenLine xmlns:a14="http://schemas.microsoft.com/office/drawing/2010/main" xmlns="" w="9525">
+                <a14:hiddenLine xmlns="" xmlns:a14="http://schemas.microsoft.com/office/drawing/2010/main" w="9525">
                   <a:solidFill>
                     <a:srgbClr val="000000"/>
                   </a:solidFill>
@@ -863,7 +863,7 @@
             </a:ln>
             <a:extLst>
               <a:ext uri="{91240B29-F687-4f45-9708-019B960494DF}">
-                <a14:hiddenLine xmlns:a14="http://schemas.microsoft.com/office/drawing/2010/main" xmlns="" w="9525">
+                <a14:hiddenLine xmlns="" xmlns:a14="http://schemas.microsoft.com/office/drawing/2010/main" w="9525">
                   <a:solidFill>
                     <a:srgbClr val="000000"/>
                   </a:solidFill>
@@ -932,7 +932,7 @@
             </a:ln>
             <a:extLst>
               <a:ext uri="{91240B29-F687-4f45-9708-019B960494DF}">
-                <a14:hiddenLine xmlns:a14="http://schemas.microsoft.com/office/drawing/2010/main" xmlns="" w="9525">
+                <a14:hiddenLine xmlns="" xmlns:a14="http://schemas.microsoft.com/office/drawing/2010/main" w="9525">
                   <a:solidFill>
                     <a:srgbClr val="000000"/>
                   </a:solidFill>
@@ -1029,7 +1029,7 @@
             </a:ln>
             <a:extLst>
               <a:ext uri="{91240B29-F687-4f45-9708-019B960494DF}">
-                <a14:hiddenLine xmlns:a14="http://schemas.microsoft.com/office/drawing/2010/main" xmlns="" w="9525">
+                <a14:hiddenLine xmlns="" xmlns:a14="http://schemas.microsoft.com/office/drawing/2010/main" w="9525">
                   <a:solidFill>
                     <a:srgbClr val="000000"/>
                   </a:solidFill>
@@ -1126,7 +1126,7 @@
             </a:ln>
             <a:extLst>
               <a:ext uri="{91240B29-F687-4f45-9708-019B960494DF}">
-                <a14:hiddenLine xmlns:a14="http://schemas.microsoft.com/office/drawing/2010/main" xmlns="" w="9525">
+                <a14:hiddenLine xmlns="" xmlns:a14="http://schemas.microsoft.com/office/drawing/2010/main" w="9525">
                   <a:solidFill>
                     <a:srgbClr val="000000"/>
                   </a:solidFill>
@@ -1195,7 +1195,7 @@
             </a:ln>
             <a:extLst>
               <a:ext uri="{91240B29-F687-4f45-9708-019B960494DF}">
-                <a14:hiddenLine xmlns:a14="http://schemas.microsoft.com/office/drawing/2010/main" xmlns="" w="9525">
+                <a14:hiddenLine xmlns="" xmlns:a14="http://schemas.microsoft.com/office/drawing/2010/main" w="9525">
                   <a:solidFill>
                     <a:srgbClr val="000000"/>
                   </a:solidFill>
@@ -1312,7 +1312,7 @@
             </a:ln>
             <a:extLst>
               <a:ext uri="{91240B29-F687-4f45-9708-019B960494DF}">
-                <a14:hiddenLine xmlns:a14="http://schemas.microsoft.com/office/drawing/2010/main" xmlns="" w="9525">
+                <a14:hiddenLine xmlns="" xmlns:a14="http://schemas.microsoft.com/office/drawing/2010/main" w="9525">
                   <a:solidFill>
                     <a:srgbClr val="000000"/>
                   </a:solidFill>
@@ -1381,7 +1381,7 @@
             </a:ln>
             <a:extLst>
               <a:ext uri="{91240B29-F687-4f45-9708-019B960494DF}">
-                <a14:hiddenLine xmlns:a14="http://schemas.microsoft.com/office/drawing/2010/main" xmlns="" w="9525">
+                <a14:hiddenLine xmlns="" xmlns:a14="http://schemas.microsoft.com/office/drawing/2010/main" w="9525">
                   <a:solidFill>
                     <a:srgbClr val="000000"/>
                   </a:solidFill>
@@ -1478,7 +1478,7 @@
             </a:ln>
             <a:extLst>
               <a:ext uri="{91240B29-F687-4f45-9708-019B960494DF}">
-                <a14:hiddenLine xmlns:a14="http://schemas.microsoft.com/office/drawing/2010/main" xmlns="" w="9525">
+                <a14:hiddenLine xmlns="" xmlns:a14="http://schemas.microsoft.com/office/drawing/2010/main" w="9525">
                   <a:solidFill>
                     <a:srgbClr val="000000"/>
                   </a:solidFill>
@@ -1575,7 +1575,7 @@
             </a:ln>
             <a:extLst>
               <a:ext uri="{91240B29-F687-4f45-9708-019B960494DF}">
-                <a14:hiddenLine xmlns:a14="http://schemas.microsoft.com/office/drawing/2010/main" xmlns="" w="9525">
+                <a14:hiddenLine xmlns="" xmlns:a14="http://schemas.microsoft.com/office/drawing/2010/main" w="9525">
                   <a:solidFill>
                     <a:srgbClr val="000000"/>
                   </a:solidFill>
@@ -1644,7 +1644,7 @@
             </a:ln>
             <a:extLst>
               <a:ext uri="{91240B29-F687-4f45-9708-019B960494DF}">
-                <a14:hiddenLine xmlns:a14="http://schemas.microsoft.com/office/drawing/2010/main" xmlns="" w="9525">
+                <a14:hiddenLine xmlns="" xmlns:a14="http://schemas.microsoft.com/office/drawing/2010/main" w="9525">
                   <a:solidFill>
                     <a:srgbClr val="000000"/>
                   </a:solidFill>
@@ -1741,7 +1741,7 @@
             </a:ln>
             <a:extLst>
               <a:ext uri="{91240B29-F687-4f45-9708-019B960494DF}">
-                <a14:hiddenLine xmlns:a14="http://schemas.microsoft.com/office/drawing/2010/main" xmlns="" w="9525">
+                <a14:hiddenLine xmlns="" xmlns:a14="http://schemas.microsoft.com/office/drawing/2010/main" w="9525">
                   <a:solidFill>
                     <a:srgbClr val="000000"/>
                   </a:solidFill>
@@ -1838,7 +1838,7 @@
             </a:ln>
             <a:extLst>
               <a:ext uri="{91240B29-F687-4f45-9708-019B960494DF}">
-                <a14:hiddenLine xmlns:a14="http://schemas.microsoft.com/office/drawing/2010/main" xmlns="" w="9525">
+                <a14:hiddenLine xmlns="" xmlns:a14="http://schemas.microsoft.com/office/drawing/2010/main" w="9525">
                   <a:solidFill>
                     <a:srgbClr val="000000"/>
                   </a:solidFill>
@@ -1901,7 +1901,7 @@
             </a:ln>
             <a:extLst>
               <a:ext uri="{91240B29-F687-4f45-9708-019B960494DF}">
-                <a14:hiddenLine xmlns:a14="http://schemas.microsoft.com/office/drawing/2010/main" xmlns="" w="9525">
+                <a14:hiddenLine xmlns="" xmlns:a14="http://schemas.microsoft.com/office/drawing/2010/main" w="9525">
                   <a:solidFill>
                     <a:srgbClr val="000000"/>
                   </a:solidFill>
@@ -1998,7 +1998,7 @@
             </a:ln>
             <a:extLst>
               <a:ext uri="{91240B29-F687-4f45-9708-019B960494DF}">
-                <a14:hiddenLine xmlns:a14="http://schemas.microsoft.com/office/drawing/2010/main" xmlns="" w="9525">
+                <a14:hiddenLine xmlns="" xmlns:a14="http://schemas.microsoft.com/office/drawing/2010/main" w="9525">
                   <a:solidFill>
                     <a:srgbClr val="000000"/>
                   </a:solidFill>
@@ -2061,7 +2061,7 @@
             </a:ln>
             <a:extLst>
               <a:ext uri="{91240B29-F687-4f45-9708-019B960494DF}">
-                <a14:hiddenLine xmlns:a14="http://schemas.microsoft.com/office/drawing/2010/main" xmlns="" w="9525">
+                <a14:hiddenLine xmlns="" xmlns:a14="http://schemas.microsoft.com/office/drawing/2010/main" w="9525">
                   <a:solidFill>
                     <a:srgbClr val="000000"/>
                   </a:solidFill>
@@ -2158,7 +2158,7 @@
             </a:ln>
             <a:extLst>
               <a:ext uri="{91240B29-F687-4f45-9708-019B960494DF}">
-                <a14:hiddenLine xmlns:a14="http://schemas.microsoft.com/office/drawing/2010/main" xmlns="" w="9525">
+                <a14:hiddenLine xmlns="" xmlns:a14="http://schemas.microsoft.com/office/drawing/2010/main" w="9525">
                   <a:solidFill>
                     <a:srgbClr val="000000"/>
                   </a:solidFill>
@@ -2233,7 +2233,7 @@
             </a:ln>
             <a:extLst>
               <a:ext uri="{91240B29-F687-4f45-9708-019B960494DF}">
-                <a14:hiddenLine xmlns:a14="http://schemas.microsoft.com/office/drawing/2010/main" xmlns="" w="9525">
+                <a14:hiddenLine xmlns="" xmlns:a14="http://schemas.microsoft.com/office/drawing/2010/main" w="9525">
                   <a:solidFill>
                     <a:srgbClr val="000000"/>
                   </a:solidFill>
@@ -2330,7 +2330,7 @@
             </a:ln>
             <a:extLst>
               <a:ext uri="{91240B29-F687-4f45-9708-019B960494DF}">
-                <a14:hiddenLine xmlns:a14="http://schemas.microsoft.com/office/drawing/2010/main" xmlns="" w="9525">
+                <a14:hiddenLine xmlns="" xmlns:a14="http://schemas.microsoft.com/office/drawing/2010/main" w="9525">
                   <a:solidFill>
                     <a:srgbClr val="000000"/>
                   </a:solidFill>
@@ -2405,7 +2405,7 @@
             </a:ln>
             <a:extLst>
               <a:ext uri="{91240B29-F687-4f45-9708-019B960494DF}">
-                <a14:hiddenLine xmlns:a14="http://schemas.microsoft.com/office/drawing/2010/main" xmlns="" w="9525">
+                <a14:hiddenLine xmlns="" xmlns:a14="http://schemas.microsoft.com/office/drawing/2010/main" w="9525">
                   <a:solidFill>
                     <a:srgbClr val="000000"/>
                   </a:solidFill>
@@ -2502,7 +2502,7 @@
             </a:ln>
             <a:extLst>
               <a:ext uri="{91240B29-F687-4f45-9708-019B960494DF}">
-                <a14:hiddenLine xmlns:a14="http://schemas.microsoft.com/office/drawing/2010/main" xmlns="" w="9525">
+                <a14:hiddenLine xmlns="" xmlns:a14="http://schemas.microsoft.com/office/drawing/2010/main" w="9525">
                   <a:solidFill>
                     <a:srgbClr val="000000"/>
                   </a:solidFill>
@@ -2543,7 +2543,7 @@
             </a:ln>
             <a:extLst>
               <a:ext uri="{91240B29-F687-4f45-9708-019B960494DF}">
-                <a14:hiddenLine xmlns:a14="http://schemas.microsoft.com/office/drawing/2010/main" xmlns="" w="9525">
+                <a14:hiddenLine xmlns="" xmlns:a14="http://schemas.microsoft.com/office/drawing/2010/main" w="9525">
                   <a:solidFill>
                     <a:srgbClr val="000000"/>
                   </a:solidFill>
@@ -2640,7 +2640,7 @@
             </a:ln>
             <a:extLst>
               <a:ext uri="{91240B29-F687-4f45-9708-019B960494DF}">
-                <a14:hiddenLine xmlns:a14="http://schemas.microsoft.com/office/drawing/2010/main" xmlns="" w="9525">
+                <a14:hiddenLine xmlns="" xmlns:a14="http://schemas.microsoft.com/office/drawing/2010/main" w="9525">
                   <a:solidFill>
                     <a:srgbClr val="000000"/>
                   </a:solidFill>
@@ -2709,7 +2709,7 @@
             </a:ln>
             <a:extLst>
               <a:ext uri="{91240B29-F687-4f45-9708-019B960494DF}">
-                <a14:hiddenLine xmlns:a14="http://schemas.microsoft.com/office/drawing/2010/main" xmlns="" w="9525">
+                <a14:hiddenLine xmlns="" xmlns:a14="http://schemas.microsoft.com/office/drawing/2010/main" w="9525">
                   <a:solidFill>
                     <a:srgbClr val="000000"/>
                   </a:solidFill>
@@ -2778,7 +2778,7 @@
             </a:ln>
             <a:extLst>
               <a:ext uri="{91240B29-F687-4f45-9708-019B960494DF}">
-                <a14:hiddenLine xmlns:a14="http://schemas.microsoft.com/office/drawing/2010/main" xmlns="" w="9525">
+                <a14:hiddenLine xmlns="" xmlns:a14="http://schemas.microsoft.com/office/drawing/2010/main" w="9525">
                   <a:solidFill>
                     <a:srgbClr val="000000"/>
                   </a:solidFill>
@@ -2875,7 +2875,7 @@
             </a:ln>
             <a:extLst>
               <a:ext uri="{91240B29-F687-4f45-9708-019B960494DF}">
-                <a14:hiddenLine xmlns:a14="http://schemas.microsoft.com/office/drawing/2010/main" xmlns="" w="9525">
+                <a14:hiddenLine xmlns="" xmlns:a14="http://schemas.microsoft.com/office/drawing/2010/main" w="9525">
                   <a:solidFill>
                     <a:srgbClr val="000000"/>
                   </a:solidFill>
@@ -2950,7 +2950,7 @@
             </a:ln>
             <a:extLst>
               <a:ext uri="{91240B29-F687-4f45-9708-019B960494DF}">
-                <a14:hiddenLine xmlns:a14="http://schemas.microsoft.com/office/drawing/2010/main" xmlns="" w="9525">
+                <a14:hiddenLine xmlns="" xmlns:a14="http://schemas.microsoft.com/office/drawing/2010/main" w="9525">
                   <a:solidFill>
                     <a:srgbClr val="000000"/>
                   </a:solidFill>
@@ -3019,7 +3019,7 @@
             </a:ln>
             <a:extLst>
               <a:ext uri="{91240B29-F687-4f45-9708-019B960494DF}">
-                <a14:hiddenLine xmlns:a14="http://schemas.microsoft.com/office/drawing/2010/main" xmlns="" w="9525">
+                <a14:hiddenLine xmlns="" xmlns:a14="http://schemas.microsoft.com/office/drawing/2010/main" w="9525">
                   <a:solidFill>
                     <a:srgbClr val="000000"/>
                   </a:solidFill>
@@ -3116,7 +3116,7 @@
             </a:ln>
             <a:extLst>
               <a:ext uri="{91240B29-F687-4f45-9708-019B960494DF}">
-                <a14:hiddenLine xmlns:a14="http://schemas.microsoft.com/office/drawing/2010/main" xmlns="" w="9525">
+                <a14:hiddenLine xmlns="" xmlns:a14="http://schemas.microsoft.com/office/drawing/2010/main" w="9525">
                   <a:solidFill>
                     <a:srgbClr val="000000"/>
                   </a:solidFill>
@@ -3185,7 +3185,7 @@
             </a:ln>
             <a:extLst>
               <a:ext uri="{91240B29-F687-4f45-9708-019B960494DF}">
-                <a14:hiddenLine xmlns:a14="http://schemas.microsoft.com/office/drawing/2010/main" xmlns="" w="9525">
+                <a14:hiddenLine xmlns="" xmlns:a14="http://schemas.microsoft.com/office/drawing/2010/main" w="9525">
                   <a:solidFill>
                     <a:srgbClr val="000000"/>
                   </a:solidFill>
@@ -3282,7 +3282,7 @@
             </a:ln>
             <a:extLst>
               <a:ext uri="{91240B29-F687-4f45-9708-019B960494DF}">
-                <a14:hiddenLine xmlns:a14="http://schemas.microsoft.com/office/drawing/2010/main" xmlns="" w="9525">
+                <a14:hiddenLine xmlns="" xmlns:a14="http://schemas.microsoft.com/office/drawing/2010/main" w="9525">
                   <a:solidFill>
                     <a:srgbClr val="000000"/>
                   </a:solidFill>
@@ -3351,7 +3351,7 @@
             </a:ln>
             <a:extLst>
               <a:ext uri="{91240B29-F687-4f45-9708-019B960494DF}">
-                <a14:hiddenLine xmlns:a14="http://schemas.microsoft.com/office/drawing/2010/main" xmlns="" w="9525">
+                <a14:hiddenLine xmlns="" xmlns:a14="http://schemas.microsoft.com/office/drawing/2010/main" w="9525">
                   <a:solidFill>
                     <a:srgbClr val="000000"/>
                   </a:solidFill>
@@ -3448,7 +3448,7 @@
             </a:ln>
             <a:extLst>
               <a:ext uri="{91240B29-F687-4f45-9708-019B960494DF}">
-                <a14:hiddenLine xmlns:a14="http://schemas.microsoft.com/office/drawing/2010/main" xmlns="" w="9525">
+                <a14:hiddenLine xmlns="" xmlns:a14="http://schemas.microsoft.com/office/drawing/2010/main" w="9525">
                   <a:solidFill>
                     <a:srgbClr val="000000"/>
                   </a:solidFill>
@@ -3489,7 +3489,7 @@
             </a:ln>
             <a:extLst>
               <a:ext uri="{91240B29-F687-4f45-9708-019B960494DF}">
-                <a14:hiddenLine xmlns:a14="http://schemas.microsoft.com/office/drawing/2010/main" xmlns="" w="9525">
+                <a14:hiddenLine xmlns="" xmlns:a14="http://schemas.microsoft.com/office/drawing/2010/main" w="9525">
                   <a:solidFill>
                     <a:srgbClr val="000000"/>
                   </a:solidFill>
@@ -3561,7 +3561,7 @@
             </a:ln>
             <a:extLst>
               <a:ext uri="{91240B29-F687-4f45-9708-019B960494DF}">
-                <a14:hiddenLine xmlns:a14="http://schemas.microsoft.com/office/drawing/2010/main" xmlns="" w="9525">
+                <a14:hiddenLine xmlns="" xmlns:a14="http://schemas.microsoft.com/office/drawing/2010/main" w="9525">
                   <a:solidFill>
                     <a:srgbClr val="000000"/>
                   </a:solidFill>
@@ -3658,7 +3658,7 @@
             </a:ln>
             <a:extLst>
               <a:ext uri="{91240B29-F687-4f45-9708-019B960494DF}">
-                <a14:hiddenLine xmlns:a14="http://schemas.microsoft.com/office/drawing/2010/main" xmlns="" w="9525">
+                <a14:hiddenLine xmlns="" xmlns:a14="http://schemas.microsoft.com/office/drawing/2010/main" w="9525">
                   <a:solidFill>
                     <a:srgbClr val="000000"/>
                   </a:solidFill>
@@ -3727,7 +3727,7 @@
             </a:ln>
             <a:extLst>
               <a:ext uri="{91240B29-F687-4f45-9708-019B960494DF}">
-                <a14:hiddenLine xmlns:a14="http://schemas.microsoft.com/office/drawing/2010/main" xmlns="" w="9525">
+                <a14:hiddenLine xmlns="" xmlns:a14="http://schemas.microsoft.com/office/drawing/2010/main" w="9525">
                   <a:solidFill>
                     <a:srgbClr val="000000"/>
                   </a:solidFill>
@@ -3824,7 +3824,7 @@
             </a:ln>
             <a:extLst>
               <a:ext uri="{91240B29-F687-4f45-9708-019B960494DF}">
-                <a14:hiddenLine xmlns:a14="http://schemas.microsoft.com/office/drawing/2010/main" xmlns="" w="9525">
+                <a14:hiddenLine xmlns="" xmlns:a14="http://schemas.microsoft.com/office/drawing/2010/main" w="9525">
                   <a:solidFill>
                     <a:srgbClr val="000000"/>
                   </a:solidFill>
@@ -3921,7 +3921,7 @@
             </a:ln>
             <a:extLst>
               <a:ext uri="{91240B29-F687-4f45-9708-019B960494DF}">
-                <a14:hiddenLine xmlns:a14="http://schemas.microsoft.com/office/drawing/2010/main" xmlns="" w="9525">
+                <a14:hiddenLine xmlns="" xmlns:a14="http://schemas.microsoft.com/office/drawing/2010/main" w="9525">
                   <a:solidFill>
                     <a:srgbClr val="000000"/>
                   </a:solidFill>
@@ -3993,7 +3993,7 @@
             </a:ln>
             <a:extLst>
               <a:ext uri="{91240B29-F687-4f45-9708-019B960494DF}">
-                <a14:hiddenLine xmlns:a14="http://schemas.microsoft.com/office/drawing/2010/main" xmlns="" w="9525">
+                <a14:hiddenLine xmlns="" xmlns:a14="http://schemas.microsoft.com/office/drawing/2010/main" w="9525">
                   <a:solidFill>
                     <a:srgbClr val="000000"/>
                   </a:solidFill>
@@ -4062,7 +4062,7 @@
             </a:ln>
             <a:extLst>
               <a:ext uri="{91240B29-F687-4f45-9708-019B960494DF}">
-                <a14:hiddenLine xmlns:a14="http://schemas.microsoft.com/office/drawing/2010/main" xmlns="" w="9525">
+                <a14:hiddenLine xmlns="" xmlns:a14="http://schemas.microsoft.com/office/drawing/2010/main" w="9525">
                   <a:solidFill>
                     <a:srgbClr val="000000"/>
                   </a:solidFill>
@@ -4159,7 +4159,7 @@
             </a:ln>
             <a:extLst>
               <a:ext uri="{91240B29-F687-4f45-9708-019B960494DF}">
-                <a14:hiddenLine xmlns:a14="http://schemas.microsoft.com/office/drawing/2010/main" xmlns="" w="9525">
+                <a14:hiddenLine xmlns="" xmlns:a14="http://schemas.microsoft.com/office/drawing/2010/main" w="9525">
                   <a:solidFill>
                     <a:srgbClr val="000000"/>
                   </a:solidFill>
@@ -4256,7 +4256,7 @@
             </a:ln>
             <a:extLst>
               <a:ext uri="{91240B29-F687-4f45-9708-019B960494DF}">
-                <a14:hiddenLine xmlns:a14="http://schemas.microsoft.com/office/drawing/2010/main" xmlns="" w="9525">
+                <a14:hiddenLine xmlns="" xmlns:a14="http://schemas.microsoft.com/office/drawing/2010/main" w="9525">
                   <a:solidFill>
                     <a:srgbClr val="000000"/>
                   </a:solidFill>
@@ -4325,7 +4325,7 @@
             </a:ln>
             <a:extLst>
               <a:ext uri="{91240B29-F687-4f45-9708-019B960494DF}">
-                <a14:hiddenLine xmlns:a14="http://schemas.microsoft.com/office/drawing/2010/main" xmlns="" w="9525">
+                <a14:hiddenLine xmlns="" xmlns:a14="http://schemas.microsoft.com/office/drawing/2010/main" w="9525">
                   <a:solidFill>
                     <a:srgbClr val="000000"/>
                   </a:solidFill>
@@ -4452,7 +4452,7 @@
             </a:ln>
             <a:extLst>
               <a:ext uri="{91240B29-F687-4f45-9708-019B960494DF}">
-                <a14:hiddenLine xmlns:a14="http://schemas.microsoft.com/office/drawing/2010/main" xmlns="" w="9525">
+                <a14:hiddenLine xmlns="" xmlns:a14="http://schemas.microsoft.com/office/drawing/2010/main" w="9525">
                   <a:solidFill>
                     <a:srgbClr val="000000"/>
                   </a:solidFill>
@@ -4527,7 +4527,7 @@
             </a:ln>
             <a:extLst>
               <a:ext uri="{91240B29-F687-4f45-9708-019B960494DF}">
-                <a14:hiddenLine xmlns:a14="http://schemas.microsoft.com/office/drawing/2010/main" xmlns="" w="9525">
+                <a14:hiddenLine xmlns="" xmlns:a14="http://schemas.microsoft.com/office/drawing/2010/main" w="9525">
                   <a:solidFill>
                     <a:srgbClr val="000000"/>
                   </a:solidFill>
@@ -4624,7 +4624,7 @@
             </a:ln>
             <a:extLst>
               <a:ext uri="{91240B29-F687-4f45-9708-019B960494DF}">
-                <a14:hiddenLine xmlns:a14="http://schemas.microsoft.com/office/drawing/2010/main" xmlns="" w="9525">
+                <a14:hiddenLine xmlns="" xmlns:a14="http://schemas.microsoft.com/office/drawing/2010/main" w="9525">
                   <a:solidFill>
                     <a:srgbClr val="000000"/>
                   </a:solidFill>
@@ -9438,7 +9438,7 @@
           <a:noFill/>
           <a:extLst>
             <a:ext uri="{909E8E84-426E-40dd-AFC4-6F175D3DCCD1}">
-              <a14:hiddenFill xmlns:a14="http://schemas.microsoft.com/office/drawing/2010/main" xmlns="">
+              <a14:hiddenFill xmlns="" xmlns:a14="http://schemas.microsoft.com/office/drawing/2010/main">
                 <a:solidFill>
                   <a:srgbClr val="FFFFFF"/>
                 </a:solidFill>
@@ -9512,7 +9512,7 @@
               </a:ln>
               <a:extLst>
                 <a:ext uri="{91240B29-F687-4f45-9708-019B960494DF}">
-                  <a14:hiddenLine xmlns:a14="http://schemas.microsoft.com/office/drawing/2010/main" xmlns="" w="9525">
+                  <a14:hiddenLine xmlns="" xmlns:a14="http://schemas.microsoft.com/office/drawing/2010/main" w="9525">
                     <a:solidFill>
                       <a:srgbClr val="000000"/>
                     </a:solidFill>
@@ -9609,7 +9609,7 @@
               </a:ln>
               <a:extLst>
                 <a:ext uri="{91240B29-F687-4f45-9708-019B960494DF}">
-                  <a14:hiddenLine xmlns:a14="http://schemas.microsoft.com/office/drawing/2010/main" xmlns="" w="9525">
+                  <a14:hiddenLine xmlns="" xmlns:a14="http://schemas.microsoft.com/office/drawing/2010/main" w="9525">
                     <a:solidFill>
                       <a:srgbClr val="000000"/>
                     </a:solidFill>
@@ -9706,7 +9706,7 @@
               </a:ln>
               <a:extLst>
                 <a:ext uri="{91240B29-F687-4f45-9708-019B960494DF}">
-                  <a14:hiddenLine xmlns:a14="http://schemas.microsoft.com/office/drawing/2010/main" xmlns="" w="9525">
+                  <a14:hiddenLine xmlns="" xmlns:a14="http://schemas.microsoft.com/office/drawing/2010/main" w="9525">
                     <a:solidFill>
                       <a:srgbClr val="000000"/>
                     </a:solidFill>
@@ -9775,7 +9775,7 @@
               </a:ln>
               <a:extLst>
                 <a:ext uri="{91240B29-F687-4f45-9708-019B960494DF}">
-                  <a14:hiddenLine xmlns:a14="http://schemas.microsoft.com/office/drawing/2010/main" xmlns="" w="9525">
+                  <a14:hiddenLine xmlns="" xmlns:a14="http://schemas.microsoft.com/office/drawing/2010/main" w="9525">
                     <a:solidFill>
                       <a:srgbClr val="000000"/>
                     </a:solidFill>
@@ -9872,7 +9872,7 @@
               </a:ln>
               <a:extLst>
                 <a:ext uri="{91240B29-F687-4f45-9708-019B960494DF}">
-                  <a14:hiddenLine xmlns:a14="http://schemas.microsoft.com/office/drawing/2010/main" xmlns="" w="9525">
+                  <a14:hiddenLine xmlns="" xmlns:a14="http://schemas.microsoft.com/office/drawing/2010/main" w="9525">
                     <a:solidFill>
                       <a:srgbClr val="000000"/>
                     </a:solidFill>
@@ -9941,7 +9941,7 @@
               </a:ln>
               <a:extLst>
                 <a:ext uri="{91240B29-F687-4f45-9708-019B960494DF}">
-                  <a14:hiddenLine xmlns:a14="http://schemas.microsoft.com/office/drawing/2010/main" xmlns="" w="9525">
+                  <a14:hiddenLine xmlns="" xmlns:a14="http://schemas.microsoft.com/office/drawing/2010/main" w="9525">
                     <a:solidFill>
                       <a:srgbClr val="000000"/>
                     </a:solidFill>
@@ -10010,7 +10010,7 @@
               </a:ln>
               <a:extLst>
                 <a:ext uri="{91240B29-F687-4f45-9708-019B960494DF}">
-                  <a14:hiddenLine xmlns:a14="http://schemas.microsoft.com/office/drawing/2010/main" xmlns="" w="9525">
+                  <a14:hiddenLine xmlns="" xmlns:a14="http://schemas.microsoft.com/office/drawing/2010/main" w="9525">
                     <a:solidFill>
                       <a:srgbClr val="000000"/>
                     </a:solidFill>
@@ -10107,7 +10107,7 @@
               </a:ln>
               <a:extLst>
                 <a:ext uri="{91240B29-F687-4f45-9708-019B960494DF}">
-                  <a14:hiddenLine xmlns:a14="http://schemas.microsoft.com/office/drawing/2010/main" xmlns="" w="9525">
+                  <a14:hiddenLine xmlns="" xmlns:a14="http://schemas.microsoft.com/office/drawing/2010/main" w="9525">
                     <a:solidFill>
                       <a:srgbClr val="000000"/>
                     </a:solidFill>
@@ -10204,7 +10204,7 @@
               </a:ln>
               <a:extLst>
                 <a:ext uri="{91240B29-F687-4f45-9708-019B960494DF}">
-                  <a14:hiddenLine xmlns:a14="http://schemas.microsoft.com/office/drawing/2010/main" xmlns="" w="9525">
+                  <a14:hiddenLine xmlns="" xmlns:a14="http://schemas.microsoft.com/office/drawing/2010/main" w="9525">
                     <a:solidFill>
                       <a:srgbClr val="000000"/>
                     </a:solidFill>
@@ -10273,7 +10273,7 @@
               </a:ln>
               <a:extLst>
                 <a:ext uri="{91240B29-F687-4f45-9708-019B960494DF}">
-                  <a14:hiddenLine xmlns:a14="http://schemas.microsoft.com/office/drawing/2010/main" xmlns="" w="9525">
+                  <a14:hiddenLine xmlns="" xmlns:a14="http://schemas.microsoft.com/office/drawing/2010/main" w="9525">
                     <a:solidFill>
                       <a:srgbClr val="000000"/>
                     </a:solidFill>
@@ -10390,7 +10390,7 @@
               </a:ln>
               <a:extLst>
                 <a:ext uri="{91240B29-F687-4f45-9708-019B960494DF}">
-                  <a14:hiddenLine xmlns:a14="http://schemas.microsoft.com/office/drawing/2010/main" xmlns="" w="9525">
+                  <a14:hiddenLine xmlns="" xmlns:a14="http://schemas.microsoft.com/office/drawing/2010/main" w="9525">
                     <a:solidFill>
                       <a:srgbClr val="000000"/>
                     </a:solidFill>
@@ -10488,7 +10488,7 @@
               </a:ln>
               <a:extLst>
                 <a:ext uri="{91240B29-F687-4f45-9708-019B960494DF}">
-                  <a14:hiddenLine xmlns:a14="http://schemas.microsoft.com/office/drawing/2010/main" xmlns="" w="9525">
+                  <a14:hiddenLine xmlns="" xmlns:a14="http://schemas.microsoft.com/office/drawing/2010/main" w="9525">
                     <a:solidFill>
                       <a:srgbClr val="000000"/>
                     </a:solidFill>
@@ -10557,7 +10557,7 @@
               </a:ln>
               <a:extLst>
                 <a:ext uri="{91240B29-F687-4f45-9708-019B960494DF}">
-                  <a14:hiddenLine xmlns:a14="http://schemas.microsoft.com/office/drawing/2010/main" xmlns="" w="9525">
+                  <a14:hiddenLine xmlns="" xmlns:a14="http://schemas.microsoft.com/office/drawing/2010/main" w="9525">
                     <a:solidFill>
                       <a:srgbClr val="000000"/>
                     </a:solidFill>
@@ -10626,7 +10626,7 @@
               </a:ln>
               <a:extLst>
                 <a:ext uri="{91240B29-F687-4f45-9708-019B960494DF}">
-                  <a14:hiddenLine xmlns:a14="http://schemas.microsoft.com/office/drawing/2010/main" xmlns="" w="9525">
+                  <a14:hiddenLine xmlns="" xmlns:a14="http://schemas.microsoft.com/office/drawing/2010/main" w="9525">
                     <a:solidFill>
                       <a:srgbClr val="000000"/>
                     </a:solidFill>
@@ -10723,7 +10723,7 @@
               </a:ln>
               <a:extLst>
                 <a:ext uri="{91240B29-F687-4f45-9708-019B960494DF}">
-                  <a14:hiddenLine xmlns:a14="http://schemas.microsoft.com/office/drawing/2010/main" xmlns="" w="9525">
+                  <a14:hiddenLine xmlns="" xmlns:a14="http://schemas.microsoft.com/office/drawing/2010/main" w="9525">
                     <a:solidFill>
                       <a:srgbClr val="000000"/>
                     </a:solidFill>
@@ -10764,7 +10764,7 @@
               </a:ln>
               <a:extLst>
                 <a:ext uri="{91240B29-F687-4f45-9708-019B960494DF}">
-                  <a14:hiddenLine xmlns:a14="http://schemas.microsoft.com/office/drawing/2010/main" xmlns="" w="9525">
+                  <a14:hiddenLine xmlns="" xmlns:a14="http://schemas.microsoft.com/office/drawing/2010/main" w="9525">
                     <a:solidFill>
                       <a:srgbClr val="000000"/>
                     </a:solidFill>
@@ -10836,7 +10836,7 @@
               </a:ln>
               <a:extLst>
                 <a:ext uri="{91240B29-F687-4f45-9708-019B960494DF}">
-                  <a14:hiddenLine xmlns:a14="http://schemas.microsoft.com/office/drawing/2010/main" xmlns="" w="9525">
+                  <a14:hiddenLine xmlns="" xmlns:a14="http://schemas.microsoft.com/office/drawing/2010/main" w="9525">
                     <a:solidFill>
                       <a:srgbClr val="000000"/>
                     </a:solidFill>
@@ -10933,7 +10933,7 @@
               </a:ln>
               <a:extLst>
                 <a:ext uri="{91240B29-F687-4f45-9708-019B960494DF}">
-                  <a14:hiddenLine xmlns:a14="http://schemas.microsoft.com/office/drawing/2010/main" xmlns="" w="9525">
+                  <a14:hiddenLine xmlns="" xmlns:a14="http://schemas.microsoft.com/office/drawing/2010/main" w="9525">
                     <a:solidFill>
                       <a:srgbClr val="000000"/>
                     </a:solidFill>
@@ -11002,7 +11002,7 @@
               </a:ln>
               <a:extLst>
                 <a:ext uri="{91240B29-F687-4f45-9708-019B960494DF}">
-                  <a14:hiddenLine xmlns:a14="http://schemas.microsoft.com/office/drawing/2010/main" xmlns="" w="9525">
+                  <a14:hiddenLine xmlns="" xmlns:a14="http://schemas.microsoft.com/office/drawing/2010/main" w="9525">
                     <a:solidFill>
                       <a:srgbClr val="000000"/>
                     </a:solidFill>
@@ -11099,7 +11099,7 @@
               </a:ln>
               <a:extLst>
                 <a:ext uri="{91240B29-F687-4f45-9708-019B960494DF}">
-                  <a14:hiddenLine xmlns:a14="http://schemas.microsoft.com/office/drawing/2010/main" xmlns="" w="9525">
+                  <a14:hiddenLine xmlns="" xmlns:a14="http://schemas.microsoft.com/office/drawing/2010/main" w="9525">
                     <a:solidFill>
                       <a:srgbClr val="000000"/>
                     </a:solidFill>
@@ -11171,7 +11171,7 @@
               </a:ln>
               <a:extLst>
                 <a:ext uri="{91240B29-F687-4f45-9708-019B960494DF}">
-                  <a14:hiddenLine xmlns:a14="http://schemas.microsoft.com/office/drawing/2010/main" xmlns="" w="9525">
+                  <a14:hiddenLine xmlns="" xmlns:a14="http://schemas.microsoft.com/office/drawing/2010/main" w="9525">
                     <a:solidFill>
                       <a:srgbClr val="000000"/>
                     </a:solidFill>
@@ -11240,7 +11240,7 @@
               </a:ln>
               <a:extLst>
                 <a:ext uri="{91240B29-F687-4f45-9708-019B960494DF}">
-                  <a14:hiddenLine xmlns:a14="http://schemas.microsoft.com/office/drawing/2010/main" xmlns="" w="9525">
+                  <a14:hiddenLine xmlns="" xmlns:a14="http://schemas.microsoft.com/office/drawing/2010/main" w="9525">
                     <a:solidFill>
                       <a:srgbClr val="000000"/>
                     </a:solidFill>
@@ -11337,7 +11337,7 @@
               </a:ln>
               <a:extLst>
                 <a:ext uri="{91240B29-F687-4f45-9708-019B960494DF}">
-                  <a14:hiddenLine xmlns:a14="http://schemas.microsoft.com/office/drawing/2010/main" xmlns="" w="9525">
+                  <a14:hiddenLine xmlns="" xmlns:a14="http://schemas.microsoft.com/office/drawing/2010/main" w="9525">
                     <a:solidFill>
                       <a:srgbClr val="000000"/>
                     </a:solidFill>
@@ -11434,7 +11434,7 @@
               </a:ln>
               <a:extLst>
                 <a:ext uri="{91240B29-F687-4f45-9708-019B960494DF}">
-                  <a14:hiddenLine xmlns:a14="http://schemas.microsoft.com/office/drawing/2010/main" xmlns="" w="9525">
+                  <a14:hiddenLine xmlns="" xmlns:a14="http://schemas.microsoft.com/office/drawing/2010/main" w="9525">
                     <a:solidFill>
                       <a:srgbClr val="000000"/>
                     </a:solidFill>
@@ -11506,7 +11506,7 @@
               </a:ln>
               <a:extLst>
                 <a:ext uri="{91240B29-F687-4f45-9708-019B960494DF}">
-                  <a14:hiddenLine xmlns:a14="http://schemas.microsoft.com/office/drawing/2010/main" xmlns="" w="9525">
+                  <a14:hiddenLine xmlns="" xmlns:a14="http://schemas.microsoft.com/office/drawing/2010/main" w="9525">
                     <a:solidFill>
                       <a:srgbClr val="000000"/>
                     </a:solidFill>
@@ -11633,7 +11633,7 @@
               </a:ln>
               <a:extLst>
                 <a:ext uri="{91240B29-F687-4f45-9708-019B960494DF}">
-                  <a14:hiddenLine xmlns:a14="http://schemas.microsoft.com/office/drawing/2010/main" xmlns="" w="9525">
+                  <a14:hiddenLine xmlns="" xmlns:a14="http://schemas.microsoft.com/office/drawing/2010/main" w="9525">
                     <a:solidFill>
                       <a:srgbClr val="000000"/>
                     </a:solidFill>
@@ -11738,7 +11738,7 @@
               </a:ln>
               <a:extLst>
                 <a:ext uri="{91240B29-F687-4f45-9708-019B960494DF}">
-                  <a14:hiddenLine xmlns:a14="http://schemas.microsoft.com/office/drawing/2010/main" xmlns="" w="9525">
+                  <a14:hiddenLine xmlns="" xmlns:a14="http://schemas.microsoft.com/office/drawing/2010/main" w="9525">
                     <a:solidFill>
                       <a:srgbClr val="000000"/>
                     </a:solidFill>
@@ -11860,7 +11860,7 @@
               </a:ln>
               <a:extLst>
                 <a:ext uri="{91240B29-F687-4f45-9708-019B960494DF}">
-                  <a14:hiddenLine xmlns:a14="http://schemas.microsoft.com/office/drawing/2010/main" xmlns="" w="9525">
+                  <a14:hiddenLine xmlns="" xmlns:a14="http://schemas.microsoft.com/office/drawing/2010/main" w="9525">
                     <a:solidFill>
                       <a:srgbClr val="000000"/>
                     </a:solidFill>
@@ -11957,7 +11957,7 @@
               </a:ln>
               <a:extLst>
                 <a:ext uri="{91240B29-F687-4f45-9708-019B960494DF}">
-                  <a14:hiddenLine xmlns:a14="http://schemas.microsoft.com/office/drawing/2010/main" xmlns="" w="9525">
+                  <a14:hiddenLine xmlns="" xmlns:a14="http://schemas.microsoft.com/office/drawing/2010/main" w="9525">
                     <a:solidFill>
                       <a:srgbClr val="000000"/>
                     </a:solidFill>
@@ -12029,7 +12029,7 @@
               </a:ln>
               <a:extLst>
                 <a:ext uri="{91240B29-F687-4f45-9708-019B960494DF}">
-                  <a14:hiddenLine xmlns:a14="http://schemas.microsoft.com/office/drawing/2010/main" xmlns="" w="9525">
+                  <a14:hiddenLine xmlns="" xmlns:a14="http://schemas.microsoft.com/office/drawing/2010/main" w="9525">
                     <a:solidFill>
                       <a:srgbClr val="000000"/>
                     </a:solidFill>
@@ -12126,7 +12126,7 @@
               </a:ln>
               <a:extLst>
                 <a:ext uri="{91240B29-F687-4f45-9708-019B960494DF}">
-                  <a14:hiddenLine xmlns:a14="http://schemas.microsoft.com/office/drawing/2010/main" xmlns="" w="9525">
+                  <a14:hiddenLine xmlns="" xmlns:a14="http://schemas.microsoft.com/office/drawing/2010/main" w="9525">
                     <a:solidFill>
                       <a:srgbClr val="000000"/>
                     </a:solidFill>
@@ -12201,7 +12201,7 @@
               </a:ln>
               <a:extLst>
                 <a:ext uri="{91240B29-F687-4f45-9708-019B960494DF}">
-                  <a14:hiddenLine xmlns:a14="http://schemas.microsoft.com/office/drawing/2010/main" xmlns="" w="9525">
+                  <a14:hiddenLine xmlns="" xmlns:a14="http://schemas.microsoft.com/office/drawing/2010/main" w="9525">
                     <a:solidFill>
                       <a:srgbClr val="000000"/>
                     </a:solidFill>
@@ -12298,7 +12298,7 @@
               </a:ln>
               <a:extLst>
                 <a:ext uri="{91240B29-F687-4f45-9708-019B960494DF}">
-                  <a14:hiddenLine xmlns:a14="http://schemas.microsoft.com/office/drawing/2010/main" xmlns="" w="9525">
+                  <a14:hiddenLine xmlns="" xmlns:a14="http://schemas.microsoft.com/office/drawing/2010/main" w="9525">
                     <a:solidFill>
                       <a:srgbClr val="000000"/>
                     </a:solidFill>
@@ -12373,7 +12373,7 @@
               </a:ln>
               <a:extLst>
                 <a:ext uri="{91240B29-F687-4f45-9708-019B960494DF}">
-                  <a14:hiddenLine xmlns:a14="http://schemas.microsoft.com/office/drawing/2010/main" xmlns="" w="9525">
+                  <a14:hiddenLine xmlns="" xmlns:a14="http://schemas.microsoft.com/office/drawing/2010/main" w="9525">
                     <a:solidFill>
                       <a:srgbClr val="000000"/>
                     </a:solidFill>
@@ -12470,7 +12470,7 @@
               </a:ln>
               <a:extLst>
                 <a:ext uri="{91240B29-F687-4f45-9708-019B960494DF}">
-                  <a14:hiddenLine xmlns:a14="http://schemas.microsoft.com/office/drawing/2010/main" xmlns="" w="9525">
+                  <a14:hiddenLine xmlns="" xmlns:a14="http://schemas.microsoft.com/office/drawing/2010/main" w="9525">
                     <a:solidFill>
                       <a:srgbClr val="000000"/>
                     </a:solidFill>
@@ -12511,7 +12511,7 @@
               </a:ln>
               <a:extLst>
                 <a:ext uri="{91240B29-F687-4f45-9708-019B960494DF}">
-                  <a14:hiddenLine xmlns:a14="http://schemas.microsoft.com/office/drawing/2010/main" xmlns="" w="9525">
+                  <a14:hiddenLine xmlns="" xmlns:a14="http://schemas.microsoft.com/office/drawing/2010/main" w="9525">
                     <a:solidFill>
                       <a:srgbClr val="000000"/>
                     </a:solidFill>
@@ -14151,7 +14151,7 @@
             <p:ph idx="1"/>
             <p:extLst>
               <p:ext uri="{D42A27DB-BD31-4B8C-83A1-F6EECF244321}">
-                <p14:modId xmlns:p14="http://schemas.microsoft.com/office/powerpoint/2010/main" val="2216124484"/>
+                <p14:modId xmlns:p14="http://schemas.microsoft.com/office/powerpoint/2010/main" val="3898264841"/>
               </p:ext>
             </p:extLst>
           </p:nvPr>
@@ -14216,6 +14216,7 @@
                     <a:bodyPr/>
                     <a:lstStyle/>
                     <a:p>
+                      <a:pPr algn="l"/>
                       <a:r>
                         <a:rPr lang="tr-TR" dirty="0"/>
                         <a:t>EKLEMLER</a:t>
@@ -14229,6 +14230,7 @@
                     <a:bodyPr/>
                     <a:lstStyle/>
                     <a:p>
+                      <a:pPr algn="ctr"/>
                       <a:r>
                         <a:rPr lang="tr-TR" dirty="0"/>
                         <a:t>HOME</a:t>
@@ -14242,6 +14244,7 @@
                     <a:bodyPr/>
                     <a:lstStyle/>
                     <a:p>
+                      <a:pPr algn="ctr"/>
                       <a:r>
                         <a:rPr lang="tr-TR" dirty="0"/>
                         <a:t>ALT SINIR</a:t>
@@ -14255,7 +14258,7 @@
                     <a:bodyPr/>
                     <a:lstStyle/>
                     <a:p>
-                      <a:pPr marL="0" marR="0" lvl="0" indent="0" algn="l" defTabSz="914400" rtl="0" eaLnBrk="1" fontAlgn="auto" latinLnBrk="0" hangingPunct="1">
+                      <a:pPr marL="0" marR="0" lvl="0" indent="0" algn="ctr" defTabSz="914400" rtl="0" eaLnBrk="1" fontAlgn="auto" latinLnBrk="0" hangingPunct="1">
                         <a:lnSpc>
                           <a:spcPct val="100000"/>
                         </a:lnSpc>
@@ -14285,9 +14288,10 @@
                     <a:bodyPr/>
                     <a:lstStyle/>
                     <a:p>
+                      <a:pPr algn="ctr"/>
                       <a:r>
                         <a:rPr lang="tr-TR" dirty="0"/>
-                        <a:t>İÇ</a:t>
+                        <a:t>+</a:t>
                       </a:r>
                     </a:p>
                   </a:txBody>
@@ -14298,9 +14302,10 @@
                     <a:bodyPr/>
                     <a:lstStyle/>
                     <a:p>
+                      <a:pPr algn="ctr"/>
                       <a:r>
                         <a:rPr lang="tr-TR" dirty="0"/>
-                        <a:t>DIŞ</a:t>
+                        <a:t>-</a:t>
                       </a:r>
                     </a:p>
                   </a:txBody>
@@ -14318,6 +14323,7 @@
                     <a:bodyPr/>
                     <a:lstStyle/>
                     <a:p>
+                      <a:pPr algn="l"/>
                       <a:r>
                         <a:rPr lang="tr-TR" dirty="0"/>
                         <a:t>L OMUZ YAW</a:t>
@@ -14376,7 +14382,7 @@
                       <a:pPr algn="ctr"/>
                       <a:r>
                         <a:rPr lang="tr-TR" dirty="0"/>
-                        <a:t>+</a:t>
+                        <a:t>İÇ</a:t>
                       </a:r>
                     </a:p>
                   </a:txBody>
@@ -14390,7 +14396,7 @@
                       <a:pPr algn="ctr"/>
                       <a:r>
                         <a:rPr lang="tr-TR" dirty="0"/>
-                        <a:t>-</a:t>
+                        <a:t>DIŞ</a:t>
                       </a:r>
                     </a:p>
                   </a:txBody>
@@ -14408,6 +14414,7 @@
                     <a:bodyPr/>
                     <a:lstStyle/>
                     <a:p>
+                      <a:pPr algn="l"/>
                       <a:r>
                         <a:rPr lang="tr-TR" dirty="0"/>
                         <a:t>L OMUZ ROLL</a:t>
@@ -14483,21 +14490,11 @@
                     <a:bodyPr/>
                     <a:lstStyle/>
                     <a:p>
+                      <a:pPr algn="l"/>
                       <a:r>
                         <a:rPr lang="tr-TR" dirty="0"/>
                         <a:t>L OMUZ PİTCH</a:t>
                       </a:r>
-                    </a:p>
-                  </a:txBody>
-                  <a:tcPr/>
-                </a:tc>
-                <a:tc>
-                  <a:txBody>
-                    <a:bodyPr/>
-                    <a:lstStyle/>
-                    <a:p>
-                      <a:pPr algn="ctr"/>
-                      <a:endParaRPr lang="tr-TR"/>
                     </a:p>
                   </a:txBody>
                   <a:tcPr/>
@@ -14546,6 +14543,17 @@
                   </a:txBody>
                   <a:tcPr/>
                 </a:tc>
+                <a:tc>
+                  <a:txBody>
+                    <a:bodyPr/>
+                    <a:lstStyle/>
+                    <a:p>
+                      <a:pPr algn="ctr"/>
+                      <a:endParaRPr lang="tr-TR" dirty="0"/>
+                    </a:p>
+                  </a:txBody>
+                  <a:tcPr/>
+                </a:tc>
                 <a:extLst>
                   <a:ext uri="{0D108BD9-81ED-4DB2-BD59-A6C34878D82A}">
                     <a16:rowId xmlns:a16="http://schemas.microsoft.com/office/drawing/2014/main" val="3725908120"/>
@@ -14558,6 +14566,7 @@
                     <a:bodyPr/>
                     <a:lstStyle/>
                     <a:p>
+                      <a:pPr algn="l"/>
                       <a:r>
                         <a:rPr lang="tr-TR" dirty="0"/>
                         <a:t>L DİRSEK</a:t>
@@ -14708,7 +14717,7 @@
                       <a:pPr algn="ctr"/>
                       <a:r>
                         <a:rPr lang="tr-TR" dirty="0"/>
-                        <a:t>+</a:t>
+                        <a:t>İÇ</a:t>
                       </a:r>
                     </a:p>
                   </a:txBody>
@@ -14722,7 +14731,7 @@
                       <a:pPr algn="ctr"/>
                       <a:r>
                         <a:rPr lang="tr-TR" dirty="0"/>
-                        <a:t>-</a:t>
+                        <a:t>DIŞ</a:t>
                       </a:r>
                     </a:p>
                   </a:txBody>
@@ -14815,7 +14824,7 @@
                       <a:pPr algn="ctr"/>
                       <a:r>
                         <a:rPr lang="tr-TR" dirty="0"/>
-                        <a:t>-</a:t>
+                        <a:t>DIŞ</a:t>
                       </a:r>
                     </a:p>
                   </a:txBody>
@@ -14829,7 +14838,7 @@
                       <a:pPr algn="ctr"/>
                       <a:r>
                         <a:rPr lang="tr-TR" dirty="0"/>
-                        <a:t>+</a:t>
+                        <a:t>İÇ</a:t>
                       </a:r>
                     </a:p>
                   </a:txBody>
@@ -15103,7 +15112,7 @@
                       <a:pPr algn="ctr"/>
                       <a:r>
                         <a:rPr lang="tr-TR" dirty="0"/>
-                        <a:t>-</a:t>
+                        <a:t>DIŞ</a:t>
                       </a:r>
                     </a:p>
                   </a:txBody>
@@ -15117,7 +15126,7 @@
                       <a:pPr algn="ctr"/>
                       <a:r>
                         <a:rPr lang="tr-TR" dirty="0"/>
-                        <a:t>+</a:t>
+                        <a:t>İÇ</a:t>
                       </a:r>
                     </a:p>
                   </a:txBody>
@@ -15135,6 +15144,7 @@
                     <a:bodyPr/>
                     <a:lstStyle/>
                     <a:p>
+                      <a:pPr algn="l"/>
                       <a:r>
                         <a:rPr lang="tr-TR" dirty="0"/>
                         <a:t>R BİLEK</a:t>
@@ -15193,7 +15203,7 @@
                       <a:pPr algn="ctr"/>
                       <a:r>
                         <a:rPr lang="tr-TR" dirty="0"/>
-                        <a:t>-</a:t>
+                        <a:t>DIŞ</a:t>
                       </a:r>
                     </a:p>
                   </a:txBody>
@@ -15207,7 +15217,7 @@
                       <a:pPr algn="ctr"/>
                       <a:r>
                         <a:rPr lang="tr-TR" dirty="0"/>
-                        <a:t>+</a:t>
+                        <a:t>İÇ</a:t>
                       </a:r>
                     </a:p>
                   </a:txBody>
@@ -15225,6 +15235,7 @@
                     <a:bodyPr/>
                     <a:lstStyle/>
                     <a:p>
+                      <a:pPr algn="l"/>
                       <a:r>
                         <a:rPr lang="tr-TR" dirty="0"/>
                         <a:t>KAFA YAW</a:t>
@@ -15283,7 +15294,7 @@
                       <a:pPr algn="ctr"/>
                       <a:r>
                         <a:rPr lang="tr-TR" dirty="0"/>
-                        <a:t>+(sol)</a:t>
+                        <a:t>SOL</a:t>
                       </a:r>
                     </a:p>
                   </a:txBody>
@@ -15297,7 +15308,7 @@
                       <a:pPr algn="ctr"/>
                       <a:r>
                         <a:rPr lang="tr-TR" dirty="0"/>
-                        <a:t>-(sağ)</a:t>
+                        <a:t>SAĞ</a:t>
                       </a:r>
                     </a:p>
                   </a:txBody>
@@ -15315,6 +15326,7 @@
                     <a:bodyPr/>
                     <a:lstStyle/>
                     <a:p>
+                      <a:pPr algn="l"/>
                       <a:r>
                         <a:rPr lang="tr-TR" dirty="0"/>
                         <a:t>KAFA PİTCH</a:t>
@@ -15370,7 +15382,7 @@
                       <a:pPr algn="ctr"/>
                       <a:r>
                         <a:rPr lang="tr-TR" dirty="0"/>
-                        <a:t>+</a:t>
+                        <a:t>İÇ</a:t>
                       </a:r>
                     </a:p>
                   </a:txBody>
@@ -15384,7 +15396,7 @@
                       <a:pPr algn="ctr"/>
                       <a:r>
                         <a:rPr lang="tr-TR" dirty="0"/>
-                        <a:t>-</a:t>
+                        <a:t>DIŞ</a:t>
                       </a:r>
                     </a:p>
                   </a:txBody>

</xml_diff>